<commit_message>
Update Air Con visual decks for topics 1.1 and 1.2
</commit_message>
<xml_diff>
--- a/05_Outputs/Air Conditioning/English Slides/Air Con Chapter 1 Topic 1.1 - Visual Lecture Deck.pptx
+++ b/05_Outputs/Air Conditioning/English Slides/Air Con Chapter 1 Topic 1.1 - Visual Lecture Deck.pptx
@@ -5093,73 +5093,6 @@
       </p:sp>
       <p:sp>
         <p:nvSpPr>
-          <p:cNvPr id="83" name="Shape 81"/>
-          <p:cNvSpPr/>
-          <p:nvPr/>
-        </p:nvSpPr>
-        <p:spPr>
-          <a:xfrm>
-            <a:off x="640080" y="5577840"/>
-            <a:ext cx="10881360" cy="566928"/>
-          </a:xfrm>
-          <a:prstGeom prst="roundRect">
-            <a:avLst>
-              <a:gd name="adj" fmla="val 12903"/>
-            </a:avLst>
-          </a:prstGeom>
-          <a:solidFill>
-            <a:srgbClr val="153243"/>
-          </a:solidFill>
-          <a:ln w="12700">
-            <a:solidFill>
-              <a:srgbClr val="153243">
-                <a:alpha val="0"/>
-              </a:srgbClr>
-            </a:solidFill>
-            <a:prstDash val="solid"/>
-          </a:ln>
-        </p:spPr>
-      </p:sp>
-      <p:sp>
-        <p:nvSpPr>
-          <p:cNvPr id="84" name="Text 82"/>
-          <p:cNvSpPr/>
-          <p:nvPr/>
-        </p:nvSpPr>
-        <p:spPr>
-          <a:xfrm>
-            <a:off x="804672" y="5715000"/>
-            <a:ext cx="10552176" cy="228600"/>
-          </a:xfrm>
-          <a:prstGeom prst="rect">
-            <a:avLst/>
-          </a:prstGeom>
-          <a:noFill/>
-          <a:ln/>
-        </p:spPr>
-        <p:txBody>
-          <a:bodyPr wrap="square" lIns="0" tIns="0" rIns="0" bIns="0" rtlCol="0" anchor="ctr">
-            <a:normAutofit/>
-          </a:bodyPr>
-          <a:lstStyle/>
-          <a:p>
-            <a:pPr indent="0" marL="0">
-              <a:buNone/>
-            </a:pPr>
-            <a:r>
-              <a:rPr lang="en-US" sz="1400" b="1" dirty="0">
-                <a:solidFill>
-                  <a:srgbClr val="FFFFFF"/>
-                </a:solidFill>
-              </a:rPr>
-              <a:t>Teaching point: peak load follows the use pattern of the space, not only the weather.</a:t>
-            </a:r>
-            <a:endParaRPr lang="en-US" sz="1400" dirty="0"/>
-          </a:p>
-        </p:txBody>
-      </p:sp>
-      <p:sp>
-        <p:nvSpPr>
           <p:cNvPr id="25" name="Slide Number Placeholder 0"/>
           <p:cNvSpPr>
             <a:spLocks noGrp="1"/>
@@ -5847,73 +5780,6 @@
       </p:sp>
       <p:sp>
         <p:nvSpPr>
-          <p:cNvPr id="21" name="Shape 19"/>
-          <p:cNvSpPr/>
-          <p:nvPr/>
-        </p:nvSpPr>
-        <p:spPr>
-          <a:xfrm>
-            <a:off x="640080" y="5577840"/>
-            <a:ext cx="10881360" cy="566928"/>
-          </a:xfrm>
-          <a:prstGeom prst="roundRect">
-            <a:avLst>
-              <a:gd name="adj" fmla="val 12903"/>
-            </a:avLst>
-          </a:prstGeom>
-          <a:solidFill>
-            <a:srgbClr val="153243"/>
-          </a:solidFill>
-          <a:ln w="12700">
-            <a:solidFill>
-              <a:srgbClr val="153243">
-                <a:alpha val="0"/>
-              </a:srgbClr>
-            </a:solidFill>
-            <a:prstDash val="solid"/>
-          </a:ln>
-        </p:spPr>
-      </p:sp>
-      <p:sp>
-        <p:nvSpPr>
-          <p:cNvPr id="22" name="Text 20"/>
-          <p:cNvSpPr/>
-          <p:nvPr/>
-        </p:nvSpPr>
-        <p:spPr>
-          <a:xfrm>
-            <a:off x="804672" y="5715000"/>
-            <a:ext cx="10552176" cy="228600"/>
-          </a:xfrm>
-          <a:prstGeom prst="rect">
-            <a:avLst/>
-          </a:prstGeom>
-          <a:noFill/>
-          <a:ln/>
-        </p:spPr>
-        <p:txBody>
-          <a:bodyPr wrap="square" lIns="0" tIns="0" rIns="0" bIns="0" rtlCol="0" anchor="ctr">
-            <a:normAutofit/>
-          </a:bodyPr>
-          <a:lstStyle/>
-          <a:p>
-            <a:pPr indent="0" marL="0">
-              <a:buNone/>
-            </a:pPr>
-            <a:r>
-              <a:rPr lang="en-US" sz="1400" b="1" dirty="0">
-                <a:solidFill>
-                  <a:srgbClr val="FFFFFF"/>
-                </a:solidFill>
-              </a:rPr>
-              <a:t>Teaching point: before calculating, define the building accurately.</a:t>
-            </a:r>
-            <a:endParaRPr lang="en-US" sz="1400" dirty="0"/>
-          </a:p>
-        </p:txBody>
-      </p:sp>
-      <p:sp>
-        <p:nvSpPr>
           <p:cNvPr id="25" name="Slide Number Placeholder 0"/>
           <p:cNvSpPr>
             <a:spLocks noGrp="1"/>
@@ -8331,73 +8197,6 @@
               <a:t>Fresh air / cleanliness</a:t>
             </a:r>
             <a:endParaRPr lang="en-US" sz="1230" dirty="0"/>
-          </a:p>
-        </p:txBody>
-      </p:sp>
-      <p:sp>
-        <p:nvSpPr>
-          <p:cNvPr id="20" name="Shape 18"/>
-          <p:cNvSpPr/>
-          <p:nvPr/>
-        </p:nvSpPr>
-        <p:spPr>
-          <a:xfrm>
-            <a:off x="640080" y="5577840"/>
-            <a:ext cx="10881360" cy="566928"/>
-          </a:xfrm>
-          <a:prstGeom prst="roundRect">
-            <a:avLst>
-              <a:gd name="adj" fmla="val 12903"/>
-            </a:avLst>
-          </a:prstGeom>
-          <a:solidFill>
-            <a:srgbClr val="153243"/>
-          </a:solidFill>
-          <a:ln w="12700">
-            <a:solidFill>
-              <a:srgbClr val="153243">
-                <a:alpha val="0"/>
-              </a:srgbClr>
-            </a:solidFill>
-            <a:prstDash val="solid"/>
-          </a:ln>
-        </p:spPr>
-      </p:sp>
-      <p:sp>
-        <p:nvSpPr>
-          <p:cNvPr id="21" name="Text 19"/>
-          <p:cNvSpPr/>
-          <p:nvPr/>
-        </p:nvSpPr>
-        <p:spPr>
-          <a:xfrm>
-            <a:off x="804672" y="5715000"/>
-            <a:ext cx="10552176" cy="228600"/>
-          </a:xfrm>
-          <a:prstGeom prst="rect">
-            <a:avLst/>
-          </a:prstGeom>
-          <a:noFill/>
-          <a:ln/>
-        </p:spPr>
-        <p:txBody>
-          <a:bodyPr wrap="square" lIns="0" tIns="0" rIns="0" bIns="0" rtlCol="0" anchor="ctr">
-            <a:normAutofit/>
-          </a:bodyPr>
-          <a:lstStyle/>
-          <a:p>
-            <a:pPr indent="0" marL="0">
-              <a:buNone/>
-            </a:pPr>
-            <a:r>
-              <a:rPr lang="en-US" sz="1400" b="1" dirty="0">
-                <a:solidFill>
-                  <a:srgbClr val="FFFFFF"/>
-                </a:solidFill>
-              </a:rPr>
-              <a:t>Teaching point: diagnose the design purpose and failed control variable before choosing equipment.</a:t>
-            </a:r>
-            <a:endParaRPr lang="en-US" sz="1400" dirty="0"/>
           </a:p>
         </p:txBody>
       </p:sp>
@@ -10040,73 +9839,6 @@
       </p:sp>
       <p:sp>
         <p:nvSpPr>
-          <p:cNvPr id="23" name="Shape 21"/>
-          <p:cNvSpPr/>
-          <p:nvPr/>
-        </p:nvSpPr>
-        <p:spPr>
-          <a:xfrm>
-            <a:off x="640080" y="5577840"/>
-            <a:ext cx="10881360" cy="566928"/>
-          </a:xfrm>
-          <a:prstGeom prst="roundRect">
-            <a:avLst>
-              <a:gd name="adj" fmla="val 12903"/>
-            </a:avLst>
-          </a:prstGeom>
-          <a:solidFill>
-            <a:srgbClr val="153243"/>
-          </a:solidFill>
-          <a:ln w="12700">
-            <a:solidFill>
-              <a:srgbClr val="153243">
-                <a:alpha val="0"/>
-              </a:srgbClr>
-            </a:solidFill>
-            <a:prstDash val="solid"/>
-          </a:ln>
-        </p:spPr>
-      </p:sp>
-      <p:sp>
-        <p:nvSpPr>
-          <p:cNvPr id="24" name="Text 22"/>
-          <p:cNvSpPr/>
-          <p:nvPr/>
-        </p:nvSpPr>
-        <p:spPr>
-          <a:xfrm>
-            <a:off x="804672" y="5715000"/>
-            <a:ext cx="10552176" cy="228600"/>
-          </a:xfrm>
-          <a:prstGeom prst="rect">
-            <a:avLst/>
-          </a:prstGeom>
-          <a:noFill/>
-          <a:ln/>
-        </p:spPr>
-        <p:txBody>
-          <a:bodyPr wrap="square" lIns="0" tIns="0" rIns="0" bIns="0" rtlCol="0" anchor="ctr">
-            <a:normAutofit/>
-          </a:bodyPr>
-          <a:lstStyle/>
-          <a:p>
-            <a:pPr indent="0" marL="0">
-              <a:buNone/>
-            </a:pPr>
-            <a:r>
-              <a:rPr lang="en-US" sz="1400" b="1" dirty="0">
-                <a:solidFill>
-                  <a:srgbClr val="FFFFFF"/>
-                </a:solidFill>
-              </a:rPr>
-              <a:t>Teaching point: air conditioning is a controlled-environment problem, not a cooling-only problem.</a:t>
-            </a:r>
-            <a:endParaRPr lang="en-US" sz="1400" dirty="0"/>
-          </a:p>
-        </p:txBody>
-      </p:sp>
-      <p:sp>
-        <p:nvSpPr>
           <p:cNvPr id="25" name="Slide Number Placeholder 0"/>
           <p:cNvSpPr>
             <a:spLocks noGrp="1"/>
@@ -10786,73 +10518,6 @@
       </p:sp>
       <p:sp>
         <p:nvSpPr>
-          <p:cNvPr id="20" name="Shape 18"/>
-          <p:cNvSpPr/>
-          <p:nvPr/>
-        </p:nvSpPr>
-        <p:spPr>
-          <a:xfrm>
-            <a:off x="640080" y="5577840"/>
-            <a:ext cx="10881360" cy="566928"/>
-          </a:xfrm>
-          <a:prstGeom prst="roundRect">
-            <a:avLst>
-              <a:gd name="adj" fmla="val 12903"/>
-            </a:avLst>
-          </a:prstGeom>
-          <a:solidFill>
-            <a:srgbClr val="153243"/>
-          </a:solidFill>
-          <a:ln w="12700">
-            <a:solidFill>
-              <a:srgbClr val="153243">
-                <a:alpha val="0"/>
-              </a:srgbClr>
-            </a:solidFill>
-            <a:prstDash val="solid"/>
-          </a:ln>
-        </p:spPr>
-      </p:sp>
-      <p:sp>
-        <p:nvSpPr>
-          <p:cNvPr id="21" name="Text 19"/>
-          <p:cNvSpPr/>
-          <p:nvPr/>
-        </p:nvSpPr>
-        <p:spPr>
-          <a:xfrm>
-            <a:off x="804672" y="5715000"/>
-            <a:ext cx="10552176" cy="228600"/>
-          </a:xfrm>
-          <a:prstGeom prst="rect">
-            <a:avLst/>
-          </a:prstGeom>
-          <a:noFill/>
-          <a:ln/>
-        </p:spPr>
-        <p:txBody>
-          <a:bodyPr wrap="square" lIns="0" tIns="0" rIns="0" bIns="0" rtlCol="0" anchor="ctr">
-            <a:normAutofit/>
-          </a:bodyPr>
-          <a:lstStyle/>
-          <a:p>
-            <a:pPr indent="0" marL="0">
-              <a:buNone/>
-            </a:pPr>
-            <a:r>
-              <a:rPr lang="en-US" sz="1400" b="1" dirty="0">
-                <a:solidFill>
-                  <a:srgbClr val="FFFFFF"/>
-                </a:solidFill>
-              </a:rPr>
-              <a:t>Teaching point: “controlled air” means four linked variables, not four independent gadgets.</a:t>
-            </a:r>
-            <a:endParaRPr lang="en-US" sz="1400" dirty="0"/>
-          </a:p>
-        </p:txBody>
-      </p:sp>
-      <p:sp>
-        <p:nvSpPr>
           <p:cNvPr id="25" name="Slide Number Placeholder 0"/>
           <p:cNvSpPr>
             <a:spLocks noGrp="1"/>
@@ -12053,73 +11718,6 @@
       </p:sp>
       <p:sp>
         <p:nvSpPr>
-          <p:cNvPr id="37" name="Shape 35"/>
-          <p:cNvSpPr/>
-          <p:nvPr/>
-        </p:nvSpPr>
-        <p:spPr>
-          <a:xfrm>
-            <a:off x="640080" y="5577840"/>
-            <a:ext cx="10881360" cy="566928"/>
-          </a:xfrm>
-          <a:prstGeom prst="roundRect">
-            <a:avLst>
-              <a:gd name="adj" fmla="val 12903"/>
-            </a:avLst>
-          </a:prstGeom>
-          <a:solidFill>
-            <a:srgbClr val="153243"/>
-          </a:solidFill>
-          <a:ln w="12700">
-            <a:solidFill>
-              <a:srgbClr val="153243">
-                <a:alpha val="0"/>
-              </a:srgbClr>
-            </a:solidFill>
-            <a:prstDash val="solid"/>
-          </a:ln>
-        </p:spPr>
-      </p:sp>
-      <p:sp>
-        <p:nvSpPr>
-          <p:cNvPr id="38" name="Text 36"/>
-          <p:cNvSpPr/>
-          <p:nvPr/>
-        </p:nvSpPr>
-        <p:spPr>
-          <a:xfrm>
-            <a:off x="804672" y="5715000"/>
-            <a:ext cx="10552176" cy="228600"/>
-          </a:xfrm>
-          <a:prstGeom prst="rect">
-            <a:avLst/>
-          </a:prstGeom>
-          <a:noFill/>
-          <a:ln/>
-        </p:spPr>
-        <p:txBody>
-          <a:bodyPr wrap="square" lIns="0" tIns="0" rIns="0" bIns="0" rtlCol="0" anchor="ctr">
-            <a:normAutofit/>
-          </a:bodyPr>
-          <a:lstStyle/>
-          <a:p>
-            <a:pPr indent="0" marL="0">
-              <a:buNone/>
-            </a:pPr>
-            <a:r>
-              <a:rPr lang="en-US" sz="1400" b="1" dirty="0">
-                <a:solidFill>
-                  <a:srgbClr val="FFFFFF"/>
-                </a:solidFill>
-              </a:rPr>
-              <a:t>Teaching point: a correct thermostat value can hide humidity, airflow, or cleanliness failure.</a:t>
-            </a:r>
-            <a:endParaRPr lang="en-US" sz="1400" dirty="0"/>
-          </a:p>
-        </p:txBody>
-      </p:sp>
-      <p:sp>
-        <p:nvSpPr>
           <p:cNvPr id="25" name="Slide Number Placeholder 0"/>
           <p:cNvSpPr>
             <a:spLocks noGrp="1"/>
@@ -12611,73 +12209,6 @@
       </p:sp>
       <p:sp>
         <p:nvSpPr>
-          <p:cNvPr id="14" name="Shape 12"/>
-          <p:cNvSpPr/>
-          <p:nvPr/>
-        </p:nvSpPr>
-        <p:spPr>
-          <a:xfrm>
-            <a:off x="640080" y="5577840"/>
-            <a:ext cx="10881360" cy="566928"/>
-          </a:xfrm>
-          <a:prstGeom prst="roundRect">
-            <a:avLst>
-              <a:gd name="adj" fmla="val 12903"/>
-            </a:avLst>
-          </a:prstGeom>
-          <a:solidFill>
-            <a:srgbClr val="153243"/>
-          </a:solidFill>
-          <a:ln w="12700">
-            <a:solidFill>
-              <a:srgbClr val="153243">
-                <a:alpha val="0"/>
-              </a:srgbClr>
-            </a:solidFill>
-            <a:prstDash val="solid"/>
-          </a:ln>
-        </p:spPr>
-      </p:sp>
-      <p:sp>
-        <p:nvSpPr>
-          <p:cNvPr id="15" name="Text 13"/>
-          <p:cNvSpPr/>
-          <p:nvPr/>
-        </p:nvSpPr>
-        <p:spPr>
-          <a:xfrm>
-            <a:off x="804672" y="5715000"/>
-            <a:ext cx="10552176" cy="228600"/>
-          </a:xfrm>
-          <a:prstGeom prst="rect">
-            <a:avLst/>
-          </a:prstGeom>
-          <a:noFill/>
-          <a:ln/>
-        </p:spPr>
-        <p:txBody>
-          <a:bodyPr wrap="square" lIns="0" tIns="0" rIns="0" bIns="0" rtlCol="0" anchor="ctr">
-            <a:normAutofit/>
-          </a:bodyPr>
-          <a:lstStyle/>
-          <a:p>
-            <a:pPr indent="0" marL="0">
-              <a:buNone/>
-            </a:pPr>
-            <a:r>
-              <a:rPr lang="en-US" sz="1400" b="1" dirty="0">
-                <a:solidFill>
-                  <a:srgbClr val="FFFFFF"/>
-                </a:solidFill>
-              </a:rPr>
-              <a:t>Teaching point: first identify the purpose; only then choose target conditions and equipment.</a:t>
-            </a:r>
-            <a:endParaRPr lang="en-US" sz="1400" dirty="0"/>
-          </a:p>
-        </p:txBody>
-      </p:sp>
-      <p:sp>
-        <p:nvSpPr>
           <p:cNvPr id="25" name="Slide Number Placeholder 0"/>
           <p:cNvSpPr>
             <a:spLocks noGrp="1"/>
@@ -13634,73 +13165,6 @@
       </p:sp>
       <p:sp>
         <p:nvSpPr>
-          <p:cNvPr id="30" name="Shape 28"/>
-          <p:cNvSpPr/>
-          <p:nvPr/>
-        </p:nvSpPr>
-        <p:spPr>
-          <a:xfrm>
-            <a:off x="640080" y="5577840"/>
-            <a:ext cx="10881360" cy="566928"/>
-          </a:xfrm>
-          <a:prstGeom prst="roundRect">
-            <a:avLst>
-              <a:gd name="adj" fmla="val 12903"/>
-            </a:avLst>
-          </a:prstGeom>
-          <a:solidFill>
-            <a:srgbClr val="153243"/>
-          </a:solidFill>
-          <a:ln w="12700">
-            <a:solidFill>
-              <a:srgbClr val="153243">
-                <a:alpha val="0"/>
-              </a:srgbClr>
-            </a:solidFill>
-            <a:prstDash val="solid"/>
-          </a:ln>
-        </p:spPr>
-      </p:sp>
-      <p:sp>
-        <p:nvSpPr>
-          <p:cNvPr id="31" name="Text 29"/>
-          <p:cNvSpPr/>
-          <p:nvPr/>
-        </p:nvSpPr>
-        <p:spPr>
-          <a:xfrm>
-            <a:off x="804672" y="5715000"/>
-            <a:ext cx="10552176" cy="228600"/>
-          </a:xfrm>
-          <a:prstGeom prst="rect">
-            <a:avLst/>
-          </a:prstGeom>
-          <a:noFill/>
-          <a:ln/>
-        </p:spPr>
-        <p:txBody>
-          <a:bodyPr wrap="square" lIns="0" tIns="0" rIns="0" bIns="0" rtlCol="0" anchor="ctr">
-            <a:normAutofit/>
-          </a:bodyPr>
-          <a:lstStyle/>
-          <a:p>
-            <a:pPr indent="0" marL="0">
-              <a:buNone/>
-            </a:pPr>
-            <a:r>
-              <a:rPr lang="en-US" sz="1400" b="1" dirty="0">
-                <a:solidFill>
-                  <a:srgbClr val="FFFFFF"/>
-                </a:solidFill>
-              </a:rPr>
-              <a:t>Teaching point: comfort is physiological heat balance, not simply low air temperature.</a:t>
-            </a:r>
-            <a:endParaRPr lang="en-US" sz="1400" dirty="0"/>
-          </a:p>
-        </p:txBody>
-      </p:sp>
-      <p:sp>
-        <p:nvSpPr>
           <p:cNvPr id="25" name="Slide Number Placeholder 0"/>
           <p:cNvSpPr>
             <a:spLocks noGrp="1"/>
@@ -14374,73 +13838,6 @@
       </p:sp>
       <p:sp>
         <p:nvSpPr>
-          <p:cNvPr id="19" name="Shape 17"/>
-          <p:cNvSpPr/>
-          <p:nvPr/>
-        </p:nvSpPr>
-        <p:spPr>
-          <a:xfrm>
-            <a:off x="640080" y="5577840"/>
-            <a:ext cx="10881360" cy="566928"/>
-          </a:xfrm>
-          <a:prstGeom prst="roundRect">
-            <a:avLst>
-              <a:gd name="adj" fmla="val 12903"/>
-            </a:avLst>
-          </a:prstGeom>
-          <a:solidFill>
-            <a:srgbClr val="153243"/>
-          </a:solidFill>
-          <a:ln w="12700">
-            <a:solidFill>
-              <a:srgbClr val="153243">
-                <a:alpha val="0"/>
-              </a:srgbClr>
-            </a:solidFill>
-            <a:prstDash val="solid"/>
-          </a:ln>
-        </p:spPr>
-      </p:sp>
-      <p:sp>
-        <p:nvSpPr>
-          <p:cNvPr id="20" name="Text 18"/>
-          <p:cNvSpPr/>
-          <p:nvPr/>
-        </p:nvSpPr>
-        <p:spPr>
-          <a:xfrm>
-            <a:off x="804672" y="5715000"/>
-            <a:ext cx="10552176" cy="228600"/>
-          </a:xfrm>
-          <a:prstGeom prst="rect">
-            <a:avLst/>
-          </a:prstGeom>
-          <a:noFill/>
-          <a:ln/>
-        </p:spPr>
-        <p:txBody>
-          <a:bodyPr wrap="square" lIns="0" tIns="0" rIns="0" bIns="0" rtlCol="0" anchor="ctr">
-            <a:normAutofit/>
-          </a:bodyPr>
-          <a:lstStyle/>
-          <a:p>
-            <a:pPr indent="0" marL="0">
-              <a:buNone/>
-            </a:pPr>
-            <a:r>
-              <a:rPr lang="en-US" sz="1400" b="1" dirty="0">
-                <a:solidFill>
-                  <a:srgbClr val="FFFFFF"/>
-                </a:solidFill>
-              </a:rPr>
-              <a:t>Teaching point: the “right” air condition is the one that protects the purpose of the space.</a:t>
-            </a:r>
-            <a:endParaRPr lang="en-US" sz="1400" dirty="0"/>
-          </a:p>
-        </p:txBody>
-      </p:sp>
-      <p:sp>
-        <p:nvSpPr>
           <p:cNvPr id="25" name="Slide Number Placeholder 0"/>
           <p:cNvSpPr>
             <a:spLocks noGrp="1"/>
@@ -15195,73 +14592,6 @@
       </p:sp>
       <p:sp>
         <p:nvSpPr>
-          <p:cNvPr id="25" name="Shape 23"/>
-          <p:cNvSpPr/>
-          <p:nvPr/>
-        </p:nvSpPr>
-        <p:spPr>
-          <a:xfrm>
-            <a:off x="640080" y="5577840"/>
-            <a:ext cx="10881360" cy="566928"/>
-          </a:xfrm>
-          <a:prstGeom prst="roundRect">
-            <a:avLst>
-              <a:gd name="adj" fmla="val 12903"/>
-            </a:avLst>
-          </a:prstGeom>
-          <a:solidFill>
-            <a:srgbClr val="153243"/>
-          </a:solidFill>
-          <a:ln w="12700">
-            <a:solidFill>
-              <a:srgbClr val="153243">
-                <a:alpha val="0"/>
-              </a:srgbClr>
-            </a:solidFill>
-            <a:prstDash val="solid"/>
-          </a:ln>
-        </p:spPr>
-      </p:sp>
-      <p:sp>
-        <p:nvSpPr>
-          <p:cNvPr id="26" name="Text 24"/>
-          <p:cNvSpPr/>
-          <p:nvPr/>
-        </p:nvSpPr>
-        <p:spPr>
-          <a:xfrm>
-            <a:off x="804672" y="5715000"/>
-            <a:ext cx="10552176" cy="228600"/>
-          </a:xfrm>
-          <a:prstGeom prst="rect">
-            <a:avLst/>
-          </a:prstGeom>
-          <a:noFill/>
-          <a:ln/>
-        </p:spPr>
-        <p:txBody>
-          <a:bodyPr wrap="square" lIns="0" tIns="0" rIns="0" bIns="0" rtlCol="0" anchor="ctr">
-            <a:normAutofit/>
-          </a:bodyPr>
-          <a:lstStyle/>
-          <a:p>
-            <a:pPr indent="0" marL="0">
-              <a:buNone/>
-            </a:pPr>
-            <a:r>
-              <a:rPr lang="en-US" sz="1400" b="1" dirty="0">
-                <a:solidFill>
-                  <a:srgbClr val="FFFFFF"/>
-                </a:solidFill>
-              </a:rPr>
-              <a:t>Teaching point: HVAC design capacity is selected for the maximum expected cooling load, not the average day.</a:t>
-            </a:r>
-            <a:endParaRPr lang="en-US" sz="1400" dirty="0"/>
-          </a:p>
-        </p:txBody>
-      </p:sp>
-      <p:sp>
-        <p:nvSpPr>
           <p:cNvPr id="25" name="Slide Number Placeholder 0"/>
           <p:cNvSpPr>
             <a:spLocks noGrp="1"/>
@@ -15993,73 +15323,6 @@
               <a:t>Office story: the building remembers the sun.</a:t>
             </a:r>
             <a:endParaRPr lang="en-US" sz="2100" dirty="0"/>
-          </a:p>
-        </p:txBody>
-      </p:sp>
-      <p:sp>
-        <p:nvSpPr>
-          <p:cNvPr id="23" name="Shape 21"/>
-          <p:cNvSpPr/>
-          <p:nvPr/>
-        </p:nvSpPr>
-        <p:spPr>
-          <a:xfrm>
-            <a:off x="640080" y="5577840"/>
-            <a:ext cx="10881360" cy="566928"/>
-          </a:xfrm>
-          <a:prstGeom prst="roundRect">
-            <a:avLst>
-              <a:gd name="adj" fmla="val 12903"/>
-            </a:avLst>
-          </a:prstGeom>
-          <a:solidFill>
-            <a:srgbClr val="153243"/>
-          </a:solidFill>
-          <a:ln w="12700">
-            <a:solidFill>
-              <a:srgbClr val="153243">
-                <a:alpha val="0"/>
-              </a:srgbClr>
-            </a:solidFill>
-            <a:prstDash val="solid"/>
-          </a:ln>
-        </p:spPr>
-      </p:sp>
-      <p:sp>
-        <p:nvSpPr>
-          <p:cNvPr id="24" name="Text 22"/>
-          <p:cNvSpPr/>
-          <p:nvPr/>
-        </p:nvSpPr>
-        <p:spPr>
-          <a:xfrm>
-            <a:off x="804672" y="5715000"/>
-            <a:ext cx="10552176" cy="228600"/>
-          </a:xfrm>
-          <a:prstGeom prst="rect">
-            <a:avLst/>
-          </a:prstGeom>
-          <a:noFill/>
-          <a:ln/>
-        </p:spPr>
-        <p:txBody>
-          <a:bodyPr wrap="square" lIns="0" tIns="0" rIns="0" bIns="0" rtlCol="0" anchor="ctr">
-            <a:normAutofit/>
-          </a:bodyPr>
-          <a:lstStyle/>
-          <a:p>
-            <a:pPr indent="0" marL="0">
-              <a:buNone/>
-            </a:pPr>
-            <a:r>
-              <a:rPr lang="en-US" sz="1400" b="1" dirty="0">
-                <a:solidFill>
-                  <a:srgbClr val="FFFFFF"/>
-                </a:solidFill>
-              </a:rPr>
-              <a:t>Teaching point: the worst hour is building-specific; do not assume noon automatically.</a:t>
-            </a:r>
-            <a:endParaRPr lang="en-US" sz="1400" dirty="0"/>
           </a:p>
         </p:txBody>
       </p:sp>

</xml_diff>